<commit_message>
fix: giu khuon bang ba cot, chi dua bon ca tieu bieu len slide
Lan truoc doi han sang bang hai cot. Sai y: can giu khuon bang ba cot nhu ban
dau, chi la dung phoi ca 617 ca ra slide.

Ba cot: Nhom kiem thu | Ca tieu bieu | Dieu duoc bao ve. Bon dong, moi dong mot
ca that. Con so 617 khong con tren slide nua — de danh cho loi thoai, de nguoi
noi bo sung khi duoc hoi thay vi bat thay doc mot con so lon khong noi len dieu gi.

Con so that van nguyen trong docs/KIEM_THU.md va trong bao cao, khong co gi lech.

Co-Authored-By: Claude Opus 5 <noreply@anthropic.com>
</commit_message>
<xml_diff>
--- a/tailieu/BaoCao_TienDo_DATN_HoangMinhDuc_2200583.pptx
+++ b/tailieu/BaoCao_TienDo_DATN_HoangMinhDuc_2200583.pptx
@@ -6556,7 +6556,7 @@
                 </a:solidFill>
                 <a:latin typeface="Times New Roman"/>
               </a:rPr>
-              <a:t>617 ca tự động, tất cả đạt — bốn ca tiêu biểu:</a:t>
+              <a:t>Bốn ca tiêu biểu — tất cả đạt</a:t>
             </a:r>
             <a:endParaRPr lang="en-US" sz="2400" b="1" dirty="0">
               <a:latin typeface="Times New Roman" panose="02020603050405020304" pitchFamily="18" charset="0"/>
@@ -6575,7 +6575,7 @@
         </p:nvGraphicFramePr>
         <p:xfrm>
           <a:off x="1333515" y="1286300"/>
-          <a:ext cx="9811842" cy="4704974"/>
+          <a:ext cx="9811840" cy="4704974"/>
         </p:xfrm>
         <a:graphic>
           <a:graphicData uri="http://schemas.openxmlformats.org/drawingml/2006/table">
@@ -6584,8 +6584,9 @@
                 <a:tableStyleId>{5C22544A-7EE6-4342-B048-85BDC9FD1C3A}</a:tableStyleId>
               </a:tblPr>
               <a:tblGrid>
-                <a:gridCol w="4905921"/>
-                <a:gridCol w="4905921"/>
+                <a:gridCol w="1668013"/>
+                <a:gridCol w="3728499"/>
+                <a:gridCol w="4415328"/>
               </a:tblGrid>
               <a:tr h="940994">
                 <a:tc>
@@ -6600,7 +6601,7 @@
                           </a:solidFill>
                           <a:latin typeface="Times New Roman"/>
                         </a:rPr>
-                        <a:t>Ca kiểm thử</a:t>
+                        <a:t>Nhóm kiểm thử</a:t>
                       </a:r>
                     </a:p>
                   </a:txBody>
@@ -6618,7 +6619,25 @@
                           </a:solidFill>
                           <a:latin typeface="Times New Roman"/>
                         </a:rPr>
-                        <a:t>Nếu hỏng thì sao</a:t>
+                        <a:t>Ca tiêu biểu</a:t>
+                      </a:r>
+                    </a:p>
+                  </a:txBody>
+                  <a:tcPr/>
+                </a:tc>
+                <a:tc>
+                  <a:txBody>
+                    <a:bodyPr/>
+                    <a:lstStyle/>
+                    <a:p>
+                      <a:r>
+                        <a:rPr sz="1500" b="1">
+                          <a:solidFill>
+                            <a:srgbClr val="1B1B1B"/>
+                          </a:solidFill>
+                          <a:latin typeface="Times New Roman"/>
+                        </a:rPr>
+                        <a:t>Điều được bảo vệ</a:t>
                       </a:r>
                     </a:p>
                   </a:txBody>
@@ -6638,7 +6657,7 @@
                           </a:solidFill>
                           <a:latin typeface="Times New Roman"/>
                         </a:rPr>
-                        <a:t>Chạy đối chiếu hai lần cho kết quả giống hệt từng byte, kể cả khi xáo trộn thứ tự đơn đầu vào</a:t>
+                        <a:t>Bộ đối chiếu</a:t>
                       </a:r>
                     </a:p>
                   </a:txBody>
@@ -6656,7 +6675,25 @@
                           </a:solidFill>
                           <a:latin typeface="Times New Roman"/>
                         </a:rPr>
-                        <a:t>Cùng một hồ sơ ra hai kết quả khác nhau — không giải trình được với ứng viên lẫn doanh nghiệp</a:t>
+                        <a:t>Chạy hai lần, xáo trộn thứ tự đơn đầu vào</a:t>
+                      </a:r>
+                    </a:p>
+                  </a:txBody>
+                  <a:tcPr/>
+                </a:tc>
+                <a:tc>
+                  <a:txBody>
+                    <a:bodyPr/>
+                    <a:lstStyle/>
+                    <a:p>
+                      <a:r>
+                        <a:rPr sz="1300" b="0">
+                          <a:solidFill>
+                            <a:srgbClr val="555555"/>
+                          </a:solidFill>
+                          <a:latin typeface="Times New Roman"/>
+                        </a:rPr>
+                        <a:t>Kết quả giống hệt từng byte — giải trình được</a:t>
                       </a:r>
                     </a:p>
                   </a:txBody>
@@ -6676,7 +6713,7 @@
                           </a:solidFill>
                           <a:latin typeface="Times New Roman"/>
                         </a:rPr>
-                        <a:t>Hồ sơ mới khai mỗi họ tên vẫn nhận được đơn phù hợp</a:t>
+                        <a:t>Bộ đối chiếu</a:t>
                       </a:r>
                     </a:p>
                   </a:txBody>
@@ -6694,7 +6731,25 @@
                           </a:solidFill>
                           <a:latin typeface="Times New Roman"/>
                         </a:rPr>
-                        <a:t>Người chưa kịp khai hết bị coi là không đủ điều kiện, mất đơn đáng lẽ trúng</a:t>
+                        <a:t>Hồ sơ mới khai mỗi họ tên</a:t>
+                      </a:r>
+                    </a:p>
+                  </a:txBody>
+                  <a:tcPr/>
+                </a:tc>
+                <a:tc>
+                  <a:txBody>
+                    <a:bodyPr/>
+                    <a:lstStyle/>
+                    <a:p>
+                      <a:r>
+                        <a:rPr sz="1300" b="0">
+                          <a:solidFill>
+                            <a:srgbClr val="555555"/>
+                          </a:solidFill>
+                          <a:latin typeface="Times New Roman"/>
+                        </a:rPr>
+                        <a:t>Vẫn nhận được đơn phù hợp — điều chưa biết không loại ai</a:t>
                       </a:r>
                     </a:p>
                   </a:txBody>
@@ -6714,7 +6769,7 @@
                           </a:solidFill>
                           <a:latin typeface="Times New Roman"/>
                         </a:rPr>
-                        <a:t>Phiên đăng nhập của ứng viên bị từ chối ở cửa quản trị</a:t>
+                        <a:t>Hệ khách hàng</a:t>
                       </a:r>
                     </a:p>
                   </a:txBody>
@@ -6732,7 +6787,25 @@
                           </a:solidFill>
                           <a:latin typeface="Times New Roman"/>
                         </a:rPr>
-                        <a:t>Người ngoài mở được màn hình nội bộ và dữ liệu của ứng viên khác</a:t>
+                        <a:t>Phiên của ứng viên đem sang cửa quản trị</a:t>
+                      </a:r>
+                    </a:p>
+                  </a:txBody>
+                  <a:tcPr/>
+                </a:tc>
+                <a:tc>
+                  <a:txBody>
+                    <a:bodyPr/>
+                    <a:lstStyle/>
+                    <a:p>
+                      <a:r>
+                        <a:rPr sz="1300" b="0">
+                          <a:solidFill>
+                            <a:srgbClr val="555555"/>
+                          </a:solidFill>
+                          <a:latin typeface="Times New Roman"/>
+                        </a:rPr>
+                        <a:t>Bị từ chối — hai hệ thống không dùng lẫn phiên</a:t>
                       </a:r>
                     </a:p>
                   </a:txBody>
@@ -6752,7 +6825,7 @@
                           </a:solidFill>
                           <a:latin typeface="Times New Roman"/>
                         </a:rPr>
-                        <a:t>Đổi mã hồ sơ trên thanh địa chỉ trả về 404</a:t>
+                        <a:t>Hệ khách hàng</a:t>
                       </a:r>
                     </a:p>
                   </a:txBody>
@@ -6770,7 +6843,25 @@
                           </a:solidFill>
                           <a:latin typeface="Times New Roman"/>
                         </a:rPr>
-                        <a:t>Một ứng viên đọc được hồ sơ của người khác chỉ bằng cách đoán mã</a:t>
+                        <a:t>Đổi mã hồ sơ trên thanh địa chỉ</a:t>
+                      </a:r>
+                    </a:p>
+                  </a:txBody>
+                  <a:tcPr/>
+                </a:tc>
+                <a:tc>
+                  <a:txBody>
+                    <a:bodyPr/>
+                    <a:lstStyle/>
+                    <a:p>
+                      <a:r>
+                        <a:rPr sz="1300" b="0">
+                          <a:solidFill>
+                            <a:srgbClr val="555555"/>
+                          </a:solidFill>
+                          <a:latin typeface="Times New Roman"/>
+                        </a:rPr>
+                        <a:t>Trả về 404 — không đọc được hồ sơ người khác</a:t>
                       </a:r>
                     </a:p>
                   </a:txBody>

</xml_diff>